<commit_message>
Move business applications slide to end of presentation handout.
Co-authored-by: Cursor <cursoragent@cursor.com>
</commit_message>
<xml_diff>
--- a/FinalProject/Deliverable4_Presentation-emmanart.pptx
+++ b/FinalProject/Deliverable4_Presentation-emmanart.pptx
@@ -584,7 +584,7 @@
           <a:lstStyle/>
           <a:p>
             <a:r>
-              <a:t>~1 min. LIVE DEMO. Expand Country → League → Match_tbl in the tree. Run SELECT COUNT(*) on each (or show counts from write-up). Open Match_tbl LIMIT 5 to show league_id, country_id, home_team_goal, away_team_goal. Mention Player_Attributes is largest (183,978) but skip opening it unless you have time.</a:t>
+              <a:t>~1 min. LIVE DEMO. Run Q16. Say: 'This is like a regional sales report—which country’s leagues produce the most goals per match.'</a:t>
             </a:r>
           </a:p>
         </p:txBody>
@@ -654,7 +654,7 @@
           <a:lstStyle/>
           <a:p>
             <a:r>
-              <a:t>~1 min. LIVE DEMO. Run Q16. Say: 'This is like a regional sales report—which country’s leagues produce the most goals per match.'</a:t>
+              <a:t>~1 min. LIVE DEMO. Run Q18. Tie to business: clean sheets = defensive reliability metric clubs track across home and away fixtures.</a:t>
             </a:r>
           </a:p>
         </p:txBody>
@@ -724,7 +724,7 @@
           <a:lstStyle/>
           <a:p>
             <a:r>
-              <a:t>~1 min. LIVE DEMO. Run Q18. Tie to business: clean sheets = defensive reliability metric clubs track across home and away fixtures.</a:t>
+              <a:t>~45 sec. Closing slide before Q&amp;A. Pick two examples. Star schema: dimensions + facts; views = canned reports for business users.</a:t>
             </a:r>
           </a:p>
         </p:txBody>
@@ -1004,7 +1004,7 @@
           <a:lstStyle/>
           <a:p>
             <a:r>
-              <a:t>~45 sec. Pick two examples. Emphasize star schema: dimensions (who/where) + facts (what happened). Views are like canned reports for business users.</a:t>
+              <a:t>~1.5 min. Walk the diagram: Country → League → Match_tbl; Team for home/away; attribute history tables. Say final ERD matches initial; views sit on top.</a:t>
             </a:r>
           </a:p>
         </p:txBody>
@@ -1074,7 +1074,7 @@
           <a:lstStyle/>
           <a:p>
             <a:r>
-              <a:t>~1.5 min. Walk the diagram: Country → League → Match_tbl; Team for home/away; attribute history tables. Say final ERD matches initial; views sit on top.</a:t>
+              <a:t>~1 min. Be specific: mention one query that was hard (e.g. Q10 unbeaten streak) or one load issue.</a:t>
             </a:r>
           </a:p>
         </p:txBody>
@@ -1144,7 +1144,7 @@
           <a:lstStyle/>
           <a:p>
             <a:r>
-              <a:t>~1 min. Be specific: mention one query that was hard (e.g. Q10 unbeaten streak) or one load issue.</a:t>
+              <a:t>~1 min. Tie learning to class topics: normalization, SQL, physical design (indexes for grad).</a:t>
             </a:r>
           </a:p>
         </p:txBody>
@@ -1214,7 +1214,7 @@
           <a:lstStyle/>
           <a:p>
             <a:r>
-              <a:t>~1 min. Tie learning to class topics: normalization, SQL, physical design (indexes for grad).</a:t>
+              <a:t>~45 sec. Honest self-assessment; mention you can read and adapt SQL you did not write before.</a:t>
             </a:r>
           </a:p>
         </p:txBody>
@@ -1284,7 +1284,7 @@
           <a:lstStyle/>
           <a:p>
             <a:r>
-              <a:t>~45 sec. Honest self-assessment; mention you can read and adapt SQL you did not write before.</a:t>
+              <a:t>~45 sec. Tie next steps to business: cleaner data + dashboards = decisions faster for ops teams.</a:t>
             </a:r>
           </a:p>
         </p:txBody>
@@ -1354,7 +1354,7 @@
           <a:lstStyle/>
           <a:p>
             <a:r>
-              <a:t>~45 sec. Tie next steps to business: cleaner data + dashboards = decisions faster for ops teams.</a:t>
+              <a:t>~1 min. LIVE DEMO. Expand Country → League → Match_tbl in the tree. Run SELECT COUNT(*) on each (or show counts from write-up). Open Match_tbl LIMIT 5 to show league_id, country_id, home_team_goal, away_team_goal. Mention Player_Attributes is largest (183,978) but skip opening it unless you have time.</a:t>
             </a:r>
           </a:p>
         </p:txBody>
@@ -4537,7 +4537,7 @@
               </a:defRPr>
             </a:pPr>
             <a:r>
-              <a:t>DEMO: Tables + row counts</a:t>
+              <a:t>DEMO: Intermediate query (Q16)</a:t>
             </a:r>
           </a:p>
           <a:p>
@@ -4550,7 +4550,7 @@
               </a:defRPr>
             </a:pPr>
             <a:r>
-              <a:t>DBeaver · schema soccer_proj</a:t>
+              <a:t>Joins + GROUP BY + AVG (no CASE)</a:t>
             </a:r>
           </a:p>
         </p:txBody>
@@ -4581,7 +4581,7 @@
               <a:spcAft>
                 <a:spcPts val="1000"/>
               </a:spcAft>
-              <a:defRPr sz="1800">
+              <a:defRPr sz="1700">
                 <a:solidFill>
                   <a:srgbClr val="212121"/>
                 </a:solidFill>
@@ -4589,7 +4589,7 @@
               </a:defRPr>
             </a:pPr>
             <a:r>
-              <a:t>Demo these core tables (foreign key relationships) in DBeaver — columns + row count:</a:t>
+              <a:t>Question: Which countries had the highest average goals per match?</a:t>
             </a:r>
           </a:p>
           <a:p>
@@ -4597,7 +4597,7 @@
               <a:spcAft>
                 <a:spcPts val="1000"/>
               </a:spcAft>
-              <a:defRPr sz="1800">
+              <a:defRPr sz="1700">
                 <a:solidFill>
                   <a:srgbClr val="212121"/>
                 </a:solidFill>
@@ -4605,7 +4605,7 @@
               </a:defRPr>
             </a:pPr>
             <a:r>
-              <a:t>Country — 11 rows (parent; League.country_id → Country.id)</a:t>
+              <a:t>Business use: compare markets (entertainment value, broadcast appeal, fan engagement)</a:t>
             </a:r>
           </a:p>
           <a:p>
@@ -4613,7 +4613,7 @@
               <a:spcAft>
                 <a:spcPts val="1000"/>
               </a:spcAft>
-              <a:defRPr sz="1800">
+              <a:defRPr sz="1700">
                 <a:solidFill>
                   <a:srgbClr val="212121"/>
                 </a:solidFill>
@@ -4621,7 +4621,7 @@
               </a:defRPr>
             </a:pPr>
             <a:r>
-              <a:t>League — 11 rows (country_id foreign key; Match_tbl.league_id → League.id)</a:t>
+              <a:t>Tables: Match_tbl → League → Country (3-table join)</a:t>
             </a:r>
           </a:p>
           <a:p>
@@ -4629,7 +4629,7 @@
               <a:spcAft>
                 <a:spcPts val="1000"/>
               </a:spcAft>
-              <a:defRPr sz="1800">
+              <a:defRPr sz="1700">
                 <a:solidFill>
                   <a:srgbClr val="212121"/>
                 </a:solidFill>
@@ -4637,39 +4637,7 @@
               </a:defRPr>
             </a:pPr>
             <a:r>
-              <a:t>Team — 299 rows (home/away team_api_id on Match_tbl)</a:t>
-            </a:r>
-          </a:p>
-          <a:p>
-            <a:pPr>
-              <a:spcAft>
-                <a:spcPts val="1000"/>
-              </a:spcAft>
-              <a:defRPr sz="1800">
-                <a:solidFill>
-                  <a:srgbClr val="212121"/>
-                </a:solidFill>
-                <a:latin typeface="Calibri"/>
-              </a:defRPr>
-            </a:pPr>
-            <a:r>
-              <a:t>Match_tbl — 25,979 rows (hub: country_id, league_id, home/away teams, goals)</a:t>
-            </a:r>
-          </a:p>
-          <a:p>
-            <a:pPr>
-              <a:spcAft>
-                <a:spcPts val="1000"/>
-              </a:spcAft>
-              <a:defRPr sz="1800">
-                <a:solidFill>
-                  <a:srgbClr val="212121"/>
-                </a:solidFill>
-                <a:latin typeface="Calibri"/>
-              </a:defRPr>
-            </a:pPr>
-            <a:r>
-              <a:t>All 7 tables combined — 222,796 rows total</a:t>
+              <a:t>Techniques: INNER JOIN (inner join), GROUP BY country, AVG of home + away goals</a:t>
             </a:r>
           </a:p>
         </p:txBody>
@@ -4723,7 +4691,7 @@
               </a:defRPr>
             </a:pPr>
             <a:r>
-              <a:t>DEMO: Intermediate query (Q16)</a:t>
+              <a:t>DEMO: Advanced query (Q18)</a:t>
             </a:r>
           </a:p>
           <a:p>
@@ -4736,7 +4704,7 @@
               </a:defRPr>
             </a:pPr>
             <a:r>
-              <a:t>Joins + GROUP BY + AVG (no CASE)</a:t>
+              <a:t>Join with OR + conditional aggregates</a:t>
             </a:r>
           </a:p>
         </p:txBody>
@@ -4775,7 +4743,7 @@
               </a:defRPr>
             </a:pPr>
             <a:r>
-              <a:t>Question: Which countries had the highest average goals per match?</a:t>
+              <a:t>Question: Which teams most frequently kept clean sheets?</a:t>
             </a:r>
           </a:p>
           <a:p>
@@ -4791,7 +4759,7 @@
               </a:defRPr>
             </a:pPr>
             <a:r>
-              <a:t>Business use: compare markets (entertainment value, broadcast appeal, fan engagement)</a:t>
+              <a:t>Business use: defensive KPI for scouting, tactics, and “best defense” style rankings</a:t>
             </a:r>
           </a:p>
           <a:p>
@@ -4807,7 +4775,7 @@
               </a:defRPr>
             </a:pPr>
             <a:r>
-              <a:t>Tables: Match_tbl → League → Country (3-table join)</a:t>
+              <a:t>Tables: Team joined to Match_tbl (team is home OR away)</a:t>
             </a:r>
           </a:p>
           <a:p>
@@ -4823,7 +4791,7 @@
               </a:defRPr>
             </a:pPr>
             <a:r>
-              <a:t>Techniques: INNER JOIN (inner join), GROUP BY country, AVG of home + away goals</a:t>
+              <a:t>Techniques: join using OR (home or away), two CASE expressions inside SUM, GROUP BY, ORDER BY</a:t>
             </a:r>
           </a:p>
         </p:txBody>
@@ -4877,7 +4845,7 @@
               </a:defRPr>
             </a:pPr>
             <a:r>
-              <a:t>DEMO: Advanced query (Q18)</a:t>
+              <a:t>Business applications</a:t>
             </a:r>
           </a:p>
           <a:p>
@@ -4890,7 +4858,7 @@
               </a:defRPr>
             </a:pPr>
             <a:r>
-              <a:t>Join with OR + conditional aggregates</a:t>
+              <a:t>Why this project matters outside class</a:t>
             </a:r>
           </a:p>
         </p:txBody>
@@ -4929,7 +4897,7 @@
               </a:defRPr>
             </a:pPr>
             <a:r>
-              <a:t>Question: Which teams most frequently kept clean sheets?</a:t>
+              <a:t>Club / league operations: season KPIs (goals, clean sheets, home vs away) for coaching and scouting</a:t>
             </a:r>
           </a:p>
           <a:p>
@@ -4945,7 +4913,7 @@
               </a:defRPr>
             </a:pPr>
             <a:r>
-              <a:t>Business use: defensive KPI for scouting, tactics, and “best defense” style rankings</a:t>
+              <a:t>Media &amp; broadcasting: compare markets (e.g. avg goals by country) for scheduling and storytelling</a:t>
             </a:r>
           </a:p>
           <a:p>
@@ -4961,7 +4929,7 @@
               </a:defRPr>
             </a:pPr>
             <a:r>
-              <a:t>Tables: Team joined to Match_tbl (team is home OR away)</a:t>
+              <a:t>Betting &amp; risk (data in Match_tbl): historical odds vs outcomes; favorite win rates</a:t>
             </a:r>
           </a:p>
           <a:p>
@@ -4977,7 +4945,23 @@
               </a:defRPr>
             </a:pPr>
             <a:r>
-              <a:t>Techniques: join using OR (home or away), two CASE expressions inside SUM, GROUP BY, ORDER BY</a:t>
+              <a:t>Talent / HR analog: Player_Attributes over time ≈ employee skill ratings for hiring and development</a:t>
+            </a:r>
+          </a:p>
+          <a:p>
+            <a:pPr>
+              <a:spcAft>
+                <a:spcPts val="1000"/>
+              </a:spcAft>
+              <a:defRPr sz="1700">
+                <a:solidFill>
+                  <a:srgbClr val="212121"/>
+                </a:solidFill>
+                <a:latin typeface="Calibri"/>
+              </a:defRPr>
+            </a:pPr>
+            <a:r>
+              <a:t>Same database patterns as retail (product sales by region) or finance (metrics over time)</a:t>
             </a:r>
           </a:p>
         </p:txBody>
@@ -5408,176 +5392,6 @@
 </file>
 
 <file path=ppt/slides/slide4.xml><?xml version="1.0" encoding="utf-8"?>
-<p:sld xmlns:a="http://schemas.openxmlformats.org/drawingml/2006/main" xmlns:p="http://schemas.openxmlformats.org/presentationml/2006/main" xmlns:r="http://schemas.openxmlformats.org/officeDocument/2006/relationships">
-  <p:cSld>
-    <p:spTree>
-      <p:nvGrpSpPr>
-        <p:cNvPr id="1" name=""/>
-        <p:cNvGrpSpPr/>
-        <p:nvPr/>
-      </p:nvGrpSpPr>
-      <p:grpSpPr/>
-      <p:sp>
-        <p:nvSpPr>
-          <p:cNvPr id="2" name="TextBox 1"/>
-          <p:cNvSpPr txBox="1"/>
-          <p:nvPr/>
-        </p:nvSpPr>
-        <p:spPr>
-          <a:xfrm>
-            <a:off x="457200" y="320040"/>
-            <a:ext cx="8229600" cy="822960"/>
-          </a:xfrm>
-          <a:prstGeom prst="rect">
-            <a:avLst/>
-          </a:prstGeom>
-          <a:noFill/>
-        </p:spPr>
-        <p:txBody>
-          <a:bodyPr wrap="none">
-            <a:spAutoFit/>
-          </a:bodyPr>
-          <a:lstStyle/>
-          <a:p>
-            <a:pPr>
-              <a:defRPr sz="3200" b="1">
-                <a:solidFill>
-                  <a:srgbClr val="1B5E20"/>
-                </a:solidFill>
-                <a:latin typeface="Calibri"/>
-              </a:defRPr>
-            </a:pPr>
-            <a:r>
-              <a:t>Business connections</a:t>
-            </a:r>
-          </a:p>
-          <a:p>
-            <a:pPr>
-              <a:defRPr sz="1600">
-                <a:solidFill>
-                  <a:srgbClr val="555555"/>
-                </a:solidFill>
-                <a:latin typeface="Calibri"/>
-              </a:defRPr>
-            </a:pPr>
-            <a:r>
-              <a:t>Why this project matters outside class</a:t>
-            </a:r>
-          </a:p>
-        </p:txBody>
-      </p:sp>
-      <p:sp>
-        <p:nvSpPr>
-          <p:cNvPr id="3" name="TextBox 2"/>
-          <p:cNvSpPr txBox="1"/>
-          <p:nvPr/>
-        </p:nvSpPr>
-        <p:spPr>
-          <a:xfrm>
-            <a:off x="548640" y="1234440"/>
-            <a:ext cx="8046720" cy="5029200"/>
-          </a:xfrm>
-          <a:prstGeom prst="rect">
-            <a:avLst/>
-          </a:prstGeom>
-          <a:noFill/>
-        </p:spPr>
-        <p:txBody>
-          <a:bodyPr wrap="square">
-            <a:spAutoFit/>
-          </a:bodyPr>
-          <a:lstStyle/>
-          <a:p>
-            <a:pPr>
-              <a:spcAft>
-                <a:spcPts val="1000"/>
-              </a:spcAft>
-              <a:defRPr sz="1700">
-                <a:solidFill>
-                  <a:srgbClr val="212121"/>
-                </a:solidFill>
-                <a:latin typeface="Calibri"/>
-              </a:defRPr>
-            </a:pPr>
-            <a:r>
-              <a:t>Club / league operations: season KPIs (goals, clean sheets, home vs away) for coaching and scouting</a:t>
-            </a:r>
-          </a:p>
-          <a:p>
-            <a:pPr>
-              <a:spcAft>
-                <a:spcPts val="1000"/>
-              </a:spcAft>
-              <a:defRPr sz="1700">
-                <a:solidFill>
-                  <a:srgbClr val="212121"/>
-                </a:solidFill>
-                <a:latin typeface="Calibri"/>
-              </a:defRPr>
-            </a:pPr>
-            <a:r>
-              <a:t>Media &amp; broadcasting: compare markets (e.g. avg goals by country) for scheduling and storytelling</a:t>
-            </a:r>
-          </a:p>
-          <a:p>
-            <a:pPr>
-              <a:spcAft>
-                <a:spcPts val="1000"/>
-              </a:spcAft>
-              <a:defRPr sz="1700">
-                <a:solidFill>
-                  <a:srgbClr val="212121"/>
-                </a:solidFill>
-                <a:latin typeface="Calibri"/>
-              </a:defRPr>
-            </a:pPr>
-            <a:r>
-              <a:t>Betting &amp; risk (data in Match_tbl): historical odds vs outcomes; favorite win rates</a:t>
-            </a:r>
-          </a:p>
-          <a:p>
-            <a:pPr>
-              <a:spcAft>
-                <a:spcPts val="1000"/>
-              </a:spcAft>
-              <a:defRPr sz="1700">
-                <a:solidFill>
-                  <a:srgbClr val="212121"/>
-                </a:solidFill>
-                <a:latin typeface="Calibri"/>
-              </a:defRPr>
-            </a:pPr>
-            <a:r>
-              <a:t>Talent / HR analog: Player_Attributes over time ≈ employee skill ratings for hiring and development</a:t>
-            </a:r>
-          </a:p>
-          <a:p>
-            <a:pPr>
-              <a:spcAft>
-                <a:spcPts val="1000"/>
-              </a:spcAft>
-              <a:defRPr sz="1700">
-                <a:solidFill>
-                  <a:srgbClr val="212121"/>
-                </a:solidFill>
-                <a:latin typeface="Calibri"/>
-              </a:defRPr>
-            </a:pPr>
-            <a:r>
-              <a:t>Same database patterns as retail (product sales by region) or finance (metrics over time)</a:t>
-            </a:r>
-          </a:p>
-        </p:txBody>
-      </p:sp>
-    </p:spTree>
-  </p:cSld>
-  <p:clrMapOvr>
-    <a:masterClrMapping/>
-  </p:clrMapOvr>
-</p:sld>
-</file>
-
-<file path=ppt/slides/slide5.xml><?xml version="1.0" encoding="utf-8"?>
 <p:sld xmlns:a="http://schemas.openxmlformats.org/drawingml/2006/main" xmlns:p="http://schemas.openxmlformats.org/presentationml/2006/main" xmlns:r="http://schemas.openxmlformats.org/officeDocument/2006/relationships">
   <p:cSld>
     <p:spTree>
@@ -5704,6 +5518,163 @@
 </p:sld>
 </file>
 
+<file path=ppt/slides/slide5.xml><?xml version="1.0" encoding="utf-8"?>
+<p:sld xmlns:a="http://schemas.openxmlformats.org/drawingml/2006/main" xmlns:p="http://schemas.openxmlformats.org/presentationml/2006/main" xmlns:r="http://schemas.openxmlformats.org/officeDocument/2006/relationships">
+  <p:cSld>
+    <p:spTree>
+      <p:nvGrpSpPr>
+        <p:cNvPr id="1" name=""/>
+        <p:cNvGrpSpPr/>
+        <p:nvPr/>
+      </p:nvGrpSpPr>
+      <p:grpSpPr/>
+      <p:sp>
+        <p:nvSpPr>
+          <p:cNvPr id="2" name="TextBox 1"/>
+          <p:cNvSpPr txBox="1"/>
+          <p:nvPr/>
+        </p:nvSpPr>
+        <p:spPr>
+          <a:xfrm>
+            <a:off x="457200" y="320040"/>
+            <a:ext cx="8229600" cy="822960"/>
+          </a:xfrm>
+          <a:prstGeom prst="rect">
+            <a:avLst/>
+          </a:prstGeom>
+          <a:noFill/>
+        </p:spPr>
+        <p:txBody>
+          <a:bodyPr wrap="none">
+            <a:spAutoFit/>
+          </a:bodyPr>
+          <a:lstStyle/>
+          <a:p>
+            <a:pPr>
+              <a:defRPr sz="3200" b="1">
+                <a:solidFill>
+                  <a:srgbClr val="1B5E20"/>
+                </a:solidFill>
+                <a:latin typeface="Calibri"/>
+              </a:defRPr>
+            </a:pPr>
+            <a:r>
+              <a:t>Hardest part</a:t>
+            </a:r>
+          </a:p>
+        </p:txBody>
+      </p:sp>
+      <p:sp>
+        <p:nvSpPr>
+          <p:cNvPr id="3" name="TextBox 2"/>
+          <p:cNvSpPr txBox="1"/>
+          <p:nvPr/>
+        </p:nvSpPr>
+        <p:spPr>
+          <a:xfrm>
+            <a:off x="548640" y="1234440"/>
+            <a:ext cx="8046720" cy="5029200"/>
+          </a:xfrm>
+          <a:prstGeom prst="rect">
+            <a:avLst/>
+          </a:prstGeom>
+          <a:noFill/>
+        </p:spPr>
+        <p:txBody>
+          <a:bodyPr wrap="square">
+            <a:spAutoFit/>
+          </a:bodyPr>
+          <a:lstStyle/>
+          <a:p>
+            <a:pPr>
+              <a:spcAft>
+                <a:spcPts val="1000"/>
+              </a:spcAft>
+              <a:defRPr sz="2000">
+                <a:solidFill>
+                  <a:srgbClr val="212121"/>
+                </a:solidFill>
+                <a:latin typeface="Calibri"/>
+              </a:defRPr>
+            </a:pPr>
+            <a:r>
+              <a:t>Loading and typing: SQLite → CSV → Postgres with consistent column names and NULL handling</a:t>
+            </a:r>
+          </a:p>
+          <a:p>
+            <a:pPr>
+              <a:spcAft>
+                <a:spcPts val="1000"/>
+              </a:spcAft>
+              <a:defRPr sz="2000">
+                <a:solidFill>
+                  <a:srgbClr val="212121"/>
+                </a:solidFill>
+                <a:latin typeface="Calibri"/>
+              </a:defRPr>
+            </a:pPr>
+            <a:r>
+              <a:t>Match_tbl is very wide (lineup API IDs, many bookmaker columns) — easy to get joins wrong</a:t>
+            </a:r>
+          </a:p>
+          <a:p>
+            <a:pPr>
+              <a:spcAft>
+                <a:spcPts val="1000"/>
+              </a:spcAft>
+              <a:defRPr sz="2000">
+                <a:solidFill>
+                  <a:srgbClr val="212121"/>
+                </a:solidFill>
+                <a:latin typeface="Calibri"/>
+              </a:defRPr>
+            </a:pPr>
+            <a:r>
+              <a:t>Writing correct multi-step SQL (common table expressions, window functions) for streaks and lineup-based ratings</a:t>
+            </a:r>
+          </a:p>
+          <a:p>
+            <a:pPr>
+              <a:spcAft>
+                <a:spcPts val="1000"/>
+              </a:spcAft>
+              <a:defRPr sz="2000">
+                <a:solidFill>
+                  <a:srgbClr val="212121"/>
+                </a:solidFill>
+                <a:latin typeface="Calibri"/>
+              </a:defRPr>
+            </a:pPr>
+            <a:r>
+              <a:t>Deciding which foreign keys to enforce vs document-only when source data has orphan keys</a:t>
+            </a:r>
+          </a:p>
+          <a:p>
+            <a:pPr>
+              <a:spcAft>
+                <a:spcPts val="1000"/>
+              </a:spcAft>
+              <a:defRPr sz="2000">
+                <a:solidFill>
+                  <a:srgbClr val="212121"/>
+                </a:solidFill>
+                <a:latin typeface="Calibri"/>
+              </a:defRPr>
+            </a:pPr>
+            <a:r>
+              <a:t>Keeping 30 project questions aligned with what the data actually supports</a:t>
+            </a:r>
+          </a:p>
+        </p:txBody>
+      </p:sp>
+    </p:spTree>
+  </p:cSld>
+  <p:clrMapOvr>
+    <a:masterClrMapping/>
+  </p:clrMapOvr>
+</p:sld>
+</file>
+
 <file path=ppt/slides/slide6.xml><?xml version="1.0" encoding="utf-8"?>
 <p:sld xmlns:a="http://schemas.openxmlformats.org/drawingml/2006/main" xmlns:p="http://schemas.openxmlformats.org/presentationml/2006/main" xmlns:r="http://schemas.openxmlformats.org/officeDocument/2006/relationships">
   <p:cSld>
@@ -5745,7 +5716,7 @@
               </a:defRPr>
             </a:pPr>
             <a:r>
-              <a:t>Hardest part</a:t>
+              <a:t>What I learned</a:t>
             </a:r>
           </a:p>
         </p:txBody>
@@ -5784,7 +5755,7 @@
               </a:defRPr>
             </a:pPr>
             <a:r>
-              <a:t>Loading and typing: SQLite → CSV → Postgres with consistent column names and NULL handling</a:t>
+              <a:t>Design first: ERD and keys matter before writing dozens of queries</a:t>
             </a:r>
           </a:p>
           <a:p>
@@ -5800,7 +5771,7 @@
               </a:defRPr>
             </a:pPr>
             <a:r>
-              <a:t>Match_tbl is very wide (lineup API IDs, many bookmaker columns) — easy to get joins wrong</a:t>
+              <a:t>JOIN choice changes results (INNER vs LEFT) — always check row counts</a:t>
             </a:r>
           </a:p>
           <a:p>
@@ -5816,7 +5787,7 @@
               </a:defRPr>
             </a:pPr>
             <a:r>
-              <a:t>Writing correct multi-step SQL (common table expressions, window functions) for streaks and lineup-based ratings</a:t>
+              <a:t>Views encapsulate repeated 4–5 table joins; indexes help filter/join columns on Match_tbl</a:t>
             </a:r>
           </a:p>
           <a:p>
@@ -5832,7 +5803,7 @@
               </a:defRPr>
             </a:pPr>
             <a:r>
-              <a:t>Deciding which foreign keys to enforce vs document-only when source data has orphan keys</a:t>
+              <a:t>Window functions (partition rows per team/season, compare to prior rows) for streaks and trends</a:t>
             </a:r>
           </a:p>
           <a:p>
@@ -5848,7 +5819,7 @@
               </a:defRPr>
             </a:pPr>
             <a:r>
-              <a:t>Keeping 30 project questions aligned with what the data actually supports</a:t>
+              <a:t>Documentation + reproducible load scripts save time at deliverable deadline</a:t>
             </a:r>
           </a:p>
         </p:txBody>
@@ -5902,7 +5873,7 @@
               </a:defRPr>
             </a:pPr>
             <a:r>
-              <a:t>What I learned</a:t>
+              <a:t>SQL confidence now</a:t>
             </a:r>
           </a:p>
         </p:txBody>
@@ -5941,7 +5912,7 @@
               </a:defRPr>
             </a:pPr>
             <a:r>
-              <a:t>Design first: ERD and keys matter before writing dozens of queries</a:t>
+              <a:t>Comfortable with the most common SQL: SELECT, JOINs, GROUP BY, HAVING, subqueries, CASE</a:t>
             </a:r>
           </a:p>
           <a:p>
@@ -5957,7 +5928,7 @@
               </a:defRPr>
             </a:pPr>
             <a:r>
-              <a:t>JOIN choice changes results (INNER vs LEFT) — always check row counts</a:t>
+              <a:t>Comfortable creating views (for example league_match_summary_view, match_context_view)</a:t>
             </a:r>
           </a:p>
           <a:p>
@@ -5973,7 +5944,7 @@
               </a:defRPr>
             </a:pPr>
             <a:r>
-              <a:t>Views encapsulate repeated 4–5 table joins; indexes help filter/join columns on Match_tbl</a:t>
+              <a:t>Overall: much more confident than at the start of the semester — I can debug by counting rows</a:t>
             </a:r>
           </a:p>
           <a:p>
@@ -5989,23 +5960,7 @@
               </a:defRPr>
             </a:pPr>
             <a:r>
-              <a:t>Window functions (partition rows per team/season, compare to prior rows) for streaks and trends</a:t>
-            </a:r>
-          </a:p>
-          <a:p>
-            <a:pPr>
-              <a:spcAft>
-                <a:spcPts val="1000"/>
-              </a:spcAft>
-              <a:defRPr sz="2000">
-                <a:solidFill>
-                  <a:srgbClr val="212121"/>
-                </a:solidFill>
-                <a:latin typeface="Calibri"/>
-              </a:defRPr>
-            </a:pPr>
-            <a:r>
-              <a:t>Documentation + reproducible load scripts save time at deliverable deadline</a:t>
+              <a:t>DBeaver plus the EXPLAIN command helped me see when a query execution plan looked expensive</a:t>
             </a:r>
           </a:p>
         </p:txBody>
@@ -6059,7 +6014,7 @@
               </a:defRPr>
             </a:pPr>
             <a:r>
-              <a:t>SQL confidence now</a:t>
+              <a:t>What I would do next (more time)</a:t>
             </a:r>
           </a:p>
         </p:txBody>
@@ -6090,7 +6045,7 @@
               <a:spcAft>
                 <a:spcPts val="1000"/>
               </a:spcAft>
-              <a:defRPr sz="2000">
+              <a:defRPr sz="1800">
                 <a:solidFill>
                   <a:srgbClr val="212121"/>
                 </a:solidFill>
@@ -6098,7 +6053,7 @@
               </a:defRPr>
             </a:pPr>
             <a:r>
-              <a:t>Comfortable with the most common SQL: SELECT, JOINs, GROUP BY, HAVING, subqueries, CASE</a:t>
+              <a:t>Enforce more foreign keys after data cleaning; add CHECK constraints on goals and dates</a:t>
             </a:r>
           </a:p>
           <a:p>
@@ -6106,7 +6061,7 @@
               <a:spcAft>
                 <a:spcPts val="1000"/>
               </a:spcAft>
-              <a:defRPr sz="2000">
+              <a:defRPr sz="1800">
                 <a:solidFill>
                   <a:srgbClr val="212121"/>
                 </a:solidFill>
@@ -6114,7 +6069,7 @@
               </a:defRPr>
             </a:pPr>
             <a:r>
-              <a:t>Comfortable creating views (for example league_match_summary_view, match_context_view)</a:t>
+              <a:t>Materialized views or summary tables for league/season dashboards</a:t>
             </a:r>
           </a:p>
           <a:p>
@@ -6122,7 +6077,7 @@
               <a:spcAft>
                 <a:spcPts val="1000"/>
               </a:spcAft>
-              <a:defRPr sz="2000">
+              <a:defRPr sz="1800">
                 <a:solidFill>
                   <a:srgbClr val="212121"/>
                 </a:solidFill>
@@ -6130,7 +6085,7 @@
               </a:defRPr>
             </a:pPr>
             <a:r>
-              <a:t>Overall: much more confident than at the start of the semester — I can debug by counting rows</a:t>
+              <a:t>More indexes tuned using EXPLAIN on the slowest of the 30 queries</a:t>
             </a:r>
           </a:p>
           <a:p>
@@ -6138,7 +6093,7 @@
               <a:spcAft>
                 <a:spcPts val="1000"/>
               </a:spcAft>
-              <a:defRPr sz="2000">
+              <a:defRPr sz="1800">
                 <a:solidFill>
                   <a:srgbClr val="212121"/>
                 </a:solidFill>
@@ -6146,7 +6101,23 @@
               </a:defRPr>
             </a:pPr>
             <a:r>
-              <a:t>DBeaver plus the EXPLAIN command helped me see when a query execution plan looked expensive</a:t>
+              <a:t>Data quality report: missing lineups, duplicate player identifiers, odds outliers</a:t>
+            </a:r>
+          </a:p>
+          <a:p>
+            <a:pPr>
+              <a:spcAft>
+                <a:spcPts val="1000"/>
+              </a:spcAft>
+              <a:defRPr sz="1800">
+                <a:solidFill>
+                  <a:srgbClr val="212121"/>
+                </a:solidFill>
+                <a:latin typeface="Calibri"/>
+              </a:defRPr>
+            </a:pPr>
+            <a:r>
+              <a:t>Optional: BI dashboard (Tableau/Power BI) on views for non-technical stakeholders</a:t>
             </a:r>
           </a:p>
         </p:txBody>
@@ -6200,7 +6171,20 @@
               </a:defRPr>
             </a:pPr>
             <a:r>
-              <a:t>What I would do next (more time)</a:t>
+              <a:t>DEMO: Tables + row counts</a:t>
+            </a:r>
+          </a:p>
+          <a:p>
+            <a:pPr>
+              <a:defRPr sz="1600">
+                <a:solidFill>
+                  <a:srgbClr val="555555"/>
+                </a:solidFill>
+                <a:latin typeface="Calibri"/>
+              </a:defRPr>
+            </a:pPr>
+            <a:r>
+              <a:t>DBeaver · schema soccer_proj</a:t>
             </a:r>
           </a:p>
         </p:txBody>
@@ -6239,7 +6223,7 @@
               </a:defRPr>
             </a:pPr>
             <a:r>
-              <a:t>Enforce more foreign keys after data cleaning; add CHECK constraints on goals and dates</a:t>
+              <a:t>Demo these core tables (foreign key relationships) in DBeaver — columns + row count:</a:t>
             </a:r>
           </a:p>
           <a:p>
@@ -6255,7 +6239,7 @@
               </a:defRPr>
             </a:pPr>
             <a:r>
-              <a:t>Materialized views or summary tables for league/season dashboards</a:t>
+              <a:t>Country — 11 rows (parent; League.country_id → Country.id)</a:t>
             </a:r>
           </a:p>
           <a:p>
@@ -6271,7 +6255,7 @@
               </a:defRPr>
             </a:pPr>
             <a:r>
-              <a:t>More indexes tuned using EXPLAIN on the slowest of the 30 queries</a:t>
+              <a:t>League — 11 rows (country_id foreign key; Match_tbl.league_id → League.id)</a:t>
             </a:r>
           </a:p>
           <a:p>
@@ -6287,7 +6271,7 @@
               </a:defRPr>
             </a:pPr>
             <a:r>
-              <a:t>Data quality report: missing lineups, duplicate player identifiers, odds outliers</a:t>
+              <a:t>Team — 299 rows (home/away team_api_id on Match_tbl)</a:t>
             </a:r>
           </a:p>
           <a:p>
@@ -6303,7 +6287,23 @@
               </a:defRPr>
             </a:pPr>
             <a:r>
-              <a:t>Optional: BI dashboard (Tableau/Power BI) on views for non-technical stakeholders</a:t>
+              <a:t>Match_tbl — 25,979 rows (hub: country_id, league_id, home/away teams, goals)</a:t>
+            </a:r>
+          </a:p>
+          <a:p>
+            <a:pPr>
+              <a:spcAft>
+                <a:spcPts val="1000"/>
+              </a:spcAft>
+              <a:defRPr sz="1800">
+                <a:solidFill>
+                  <a:srgbClr val="212121"/>
+                </a:solidFill>
+                <a:latin typeface="Calibri"/>
+              </a:defRPr>
+            </a:pPr>
+            <a:r>
+              <a:t>All 7 tables combined — 222,796 rows total</a:t>
             </a:r>
           </a:p>
         </p:txBody>

</xml_diff>

<commit_message>
Add Deliverable 4 presentation deep-dive guide and demo assets.
Document explains every slide in the 8-minute handout (ERD, reflection,
Q16/Q18 SQL and screenshots). Update pptx with embedded demo results,
spy-schema homework SQL helpers, and Homework 4 docx alignment.

Co-authored-by: Cursor <cursoragent@cursor.com>
</commit_message>
<xml_diff>
--- a/FinalProject/Deliverable4_Presentation-emmanart.pptx
+++ b/FinalProject/Deliverable4_Presentation-emmanart.pptx
@@ -18,6 +18,8 @@
     <p:sldId id="266" r:id="rId18"/>
     <p:sldId id="267" r:id="rId19"/>
     <p:sldId id="268" r:id="rId20"/>
+    <p:sldId id="269" r:id="rId21"/>
+    <p:sldId id="270" r:id="rId22"/>
   </p:sldIdLst>
   <p:sldSz cx="9144000" cy="6858000" type="screen4x3"/>
   <p:notesSz cx="6858000" cy="9144000"/>
@@ -584,7 +586,49 @@
           <a:lstStyle/>
           <a:p>
             <a:r>
-              <a:t>~1 min. LIVE DEMO. Run Q16. Say: 'This is like a regional sales report—which country’s leagues produce the most goals per match.'</a:t>
+              <a:t>~1 min. LIVE DEMO. Run Q16.</a:t>
+            </a:r>
+          </a:p>
+          <a:p/>
+          <a:p>
+            <a:r>
+              <a:t>SELECT c.name AS country,</a:t>
+            </a:r>
+          </a:p>
+          <a:p>
+            <a:r>
+              <a:t>  AVG((m.home_team_goal + m.away_team_goal)::numeric) AS avg_goals_per_match</a:t>
+            </a:r>
+          </a:p>
+          <a:p>
+            <a:r>
+              <a:t>FROM soccer_proj."Match_tbl" m</a:t>
+            </a:r>
+          </a:p>
+          <a:p>
+            <a:r>
+              <a:t>JOIN soccer_proj."League" l ON l.id = m.league_id</a:t>
+            </a:r>
+          </a:p>
+          <a:p>
+            <a:r>
+              <a:t>JOIN soccer_proj."Country" c ON c.id = l.country_id</a:t>
+            </a:r>
+          </a:p>
+          <a:p>
+            <a:r>
+              <a:t>GROUP BY c.name</a:t>
+            </a:r>
+          </a:p>
+          <a:p>
+            <a:r>
+              <a:t>ORDER BY avg_goals_per_match DESC;</a:t>
+            </a:r>
+          </a:p>
+          <a:p/>
+          <a:p>
+            <a:r>
+              <a:t>Say: regional report—which country’s leagues produce the most goals per match.</a:t>
             </a:r>
           </a:p>
         </p:txBody>
@@ -654,7 +698,7 @@
           <a:lstStyle/>
           <a:p>
             <a:r>
-              <a:t>~1 min. LIVE DEMO. Run Q18. Tie to business: clean sheets = defensive reliability metric clubs track across home and away fixtures.</a:t>
+              <a:t>~30 sec. Show this screenshot or live results. Highlight top countries (Netherlands, Switzerland, Germany).</a:t>
             </a:r>
           </a:p>
         </p:txBody>
@@ -724,7 +768,59 @@
           <a:lstStyle/>
           <a:p>
             <a:r>
-              <a:t>~45 sec. Closing slide before Q&amp;A. Pick two examples. Star schema: dimensions + facts; views = canned reports for business users.</a:t>
+              <a:t>~1 min. LIVE DEMO. Run Q18.</a:t>
+            </a:r>
+          </a:p>
+          <a:p/>
+          <a:p>
+            <a:r>
+              <a:t>SELECT t.team_long_name,</a:t>
+            </a:r>
+          </a:p>
+          <a:p>
+            <a:r>
+              <a:t>  SUM(CASE WHEN m.home_team_api_id = t.team_api_id AND m.away_team_goal = 0 THEN 1 ELSE 0 END</a:t>
+            </a:r>
+          </a:p>
+          <a:p>
+            <a:r>
+              <a:t>     + CASE WHEN m.away_team_api_id = t.team_api_id AND m.home_team_goal = 0 THEN 1 ELSE 0 END) AS clean_sheets</a:t>
+            </a:r>
+          </a:p>
+          <a:p>
+            <a:r>
+              <a:t>FROM soccer_proj."Team" t</a:t>
+            </a:r>
+          </a:p>
+          <a:p>
+            <a:r>
+              <a:t>JOIN soccer_proj."Match_tbl" m</a:t>
+            </a:r>
+          </a:p>
+          <a:p>
+            <a:r>
+              <a:t>  ON m.home_team_api_id = t.team_api_id OR m.away_team_api_id = t.team_api_id</a:t>
+            </a:r>
+          </a:p>
+          <a:p>
+            <a:r>
+              <a:t>GROUP BY t.team_long_name</a:t>
+            </a:r>
+          </a:p>
+          <a:p>
+            <a:r>
+              <a:t>ORDER BY clean_sheets DESC</a:t>
+            </a:r>
+          </a:p>
+          <a:p>
+            <a:r>
+              <a:t>LIMIT 30;</a:t>
+            </a:r>
+          </a:p>
+          <a:p/>
+          <a:p>
+            <a:r>
+              <a:t>Clean sheets = defensive KPI clubs track home and away.</a:t>
             </a:r>
           </a:p>
         </p:txBody>
@@ -750,6 +846,146 @@
 </file>
 
 <file path=ppt/notesSlides/notesSlide13.xml><?xml version="1.0" encoding="utf-8"?>
+<p:notes xmlns:a="http://schemas.openxmlformats.org/drawingml/2006/main" xmlns:p="http://schemas.openxmlformats.org/presentationml/2006/main" xmlns:r="http://schemas.openxmlformats.org/officeDocument/2006/relationships">
+  <p:cSld>
+    <p:spTree>
+      <p:nvGrpSpPr>
+        <p:cNvPr id="1" name=""/>
+        <p:cNvGrpSpPr/>
+        <p:nvPr/>
+      </p:nvGrpSpPr>
+      <p:grpSpPr>
+        <a:xfrm>
+          <a:off x="0" y="0"/>
+          <a:ext cx="0" cy="0"/>
+          <a:chOff x="0" y="0"/>
+          <a:chExt cx="0" cy="0"/>
+        </a:xfrm>
+      </p:grpSpPr>
+      <p:sp>
+        <p:nvSpPr>
+          <p:cNvPr id="2" name="Slide Image Placeholder 1"/>
+          <p:cNvSpPr>
+            <a:spLocks noGrp="1"/>
+          </p:cNvSpPr>
+          <p:nvPr>
+            <p:ph type="sldImg" idx="2"/>
+          </p:nvPr>
+        </p:nvSpPr>
+        <p:spPr/>
+      </p:sp>
+      <p:sp>
+        <p:nvSpPr>
+          <p:cNvPr id="3" name="Notes Placeholder 2"/>
+          <p:cNvSpPr>
+            <a:spLocks noGrp="1"/>
+          </p:cNvSpPr>
+          <p:nvPr>
+            <p:ph type="body" idx="3" sz="quarter"/>
+          </p:nvPr>
+        </p:nvSpPr>
+        <p:spPr/>
+        <p:txBody>
+          <a:bodyPr/>
+          <a:lstStyle/>
+          <a:p>
+            <a:r>
+              <a:t>~30 sec. Show screenshot or live results. Celtic, Barcelona, Manchester United at top.</a:t>
+            </a:r>
+          </a:p>
+        </p:txBody>
+      </p:sp>
+      <p:sp>
+        <p:nvSpPr>
+          <p:cNvPr id="4" name="Slide Number Placeholder 3"/>
+          <p:cNvSpPr>
+            <a:spLocks noGrp="1"/>
+          </p:cNvSpPr>
+          <p:nvPr>
+            <p:ph type="sldNum" idx="5" sz="quarter"/>
+          </p:nvPr>
+        </p:nvSpPr>
+        <p:spPr/>
+      </p:sp>
+    </p:spTree>
+  </p:cSld>
+  <p:clrMapOvr>
+    <a:masterClrMapping/>
+  </p:clrMapOvr>
+</p:notes>
+</file>
+
+<file path=ppt/notesSlides/notesSlide14.xml><?xml version="1.0" encoding="utf-8"?>
+<p:notes xmlns:a="http://schemas.openxmlformats.org/drawingml/2006/main" xmlns:p="http://schemas.openxmlformats.org/presentationml/2006/main" xmlns:r="http://schemas.openxmlformats.org/officeDocument/2006/relationships">
+  <p:cSld>
+    <p:spTree>
+      <p:nvGrpSpPr>
+        <p:cNvPr id="1" name=""/>
+        <p:cNvGrpSpPr/>
+        <p:nvPr/>
+      </p:nvGrpSpPr>
+      <p:grpSpPr>
+        <a:xfrm>
+          <a:off x="0" y="0"/>
+          <a:ext cx="0" cy="0"/>
+          <a:chOff x="0" y="0"/>
+          <a:chExt cx="0" cy="0"/>
+        </a:xfrm>
+      </p:grpSpPr>
+      <p:sp>
+        <p:nvSpPr>
+          <p:cNvPr id="2" name="Slide Image Placeholder 1"/>
+          <p:cNvSpPr>
+            <a:spLocks noGrp="1"/>
+          </p:cNvSpPr>
+          <p:nvPr>
+            <p:ph type="sldImg" idx="2"/>
+          </p:nvPr>
+        </p:nvSpPr>
+        <p:spPr/>
+      </p:sp>
+      <p:sp>
+        <p:nvSpPr>
+          <p:cNvPr id="3" name="Notes Placeholder 2"/>
+          <p:cNvSpPr>
+            <a:spLocks noGrp="1"/>
+          </p:cNvSpPr>
+          <p:nvPr>
+            <p:ph type="body" idx="3" sz="quarter"/>
+          </p:nvPr>
+        </p:nvSpPr>
+        <p:spPr/>
+        <p:txBody>
+          <a:bodyPr/>
+          <a:lstStyle/>
+          <a:p>
+            <a:r>
+              <a:t>~45 sec. Closing slide before Q&amp;A. Pick two examples. Star schema: dimensions + facts; views = canned reports for business users.</a:t>
+            </a:r>
+          </a:p>
+        </p:txBody>
+      </p:sp>
+      <p:sp>
+        <p:nvSpPr>
+          <p:cNvPr id="4" name="Slide Number Placeholder 3"/>
+          <p:cNvSpPr>
+            <a:spLocks noGrp="1"/>
+          </p:cNvSpPr>
+          <p:nvPr>
+            <p:ph type="sldNum" idx="5" sz="quarter"/>
+          </p:nvPr>
+        </p:nvSpPr>
+        <p:spPr/>
+      </p:sp>
+    </p:spTree>
+  </p:cSld>
+  <p:clrMapOvr>
+    <a:masterClrMapping/>
+  </p:clrMapOvr>
+</p:notes>
+</file>
+
+<file path=ppt/notesSlides/notesSlide15.xml><?xml version="1.0" encoding="utf-8"?>
 <p:notes xmlns:a="http://schemas.openxmlformats.org/drawingml/2006/main" xmlns:p="http://schemas.openxmlformats.org/presentationml/2006/main" xmlns:r="http://schemas.openxmlformats.org/officeDocument/2006/relationships">
   <p:cSld>
     <p:spTree>
@@ -4563,8 +4799,8 @@
         </p:nvSpPr>
         <p:spPr>
           <a:xfrm>
-            <a:off x="548640" y="1234440"/>
-            <a:ext cx="8046720" cy="5029200"/>
+            <a:off x="548640" y="1143000"/>
+            <a:ext cx="8046720" cy="1920240"/>
           </a:xfrm>
           <a:prstGeom prst="rect">
             <a:avLst/>
@@ -4581,7 +4817,7 @@
               <a:spcAft>
                 <a:spcPts val="1000"/>
               </a:spcAft>
-              <a:defRPr sz="1700">
+              <a:defRPr sz="1600">
                 <a:solidFill>
                   <a:srgbClr val="212121"/>
                 </a:solidFill>
@@ -4597,7 +4833,7 @@
               <a:spcAft>
                 <a:spcPts val="1000"/>
               </a:spcAft>
-              <a:defRPr sz="1700">
+              <a:defRPr sz="1600">
                 <a:solidFill>
                   <a:srgbClr val="212121"/>
                 </a:solidFill>
@@ -4605,39 +4841,83 @@
               </a:defRPr>
             </a:pPr>
             <a:r>
-              <a:t>Business use: compare markets (entertainment value, broadcast appeal, fan engagement)</a:t>
-            </a:r>
-          </a:p>
+              <a:t>Tables: Match_tbl → League → Country · INNER JOIN, GROUP BY, AVG (no CASE)</a:t>
+            </a:r>
+          </a:p>
+        </p:txBody>
+      </p:sp>
+      <p:sp>
+        <p:nvSpPr>
+          <p:cNvPr id="4" name="TextBox 3"/>
+          <p:cNvSpPr txBox="1"/>
+          <p:nvPr/>
+        </p:nvSpPr>
+        <p:spPr>
+          <a:xfrm>
+            <a:off x="502920" y="3246120"/>
+            <a:ext cx="8138160" cy="3200400"/>
+          </a:xfrm>
+          <a:prstGeom prst="rect">
+            <a:avLst/>
+          </a:prstGeom>
+          <a:noFill/>
+        </p:spPr>
+        <p:txBody>
+          <a:bodyPr wrap="square">
+            <a:spAutoFit/>
+          </a:bodyPr>
+          <a:lstStyle/>
           <a:p>
             <a:pPr>
-              <a:spcAft>
-                <a:spcPts val="1000"/>
-              </a:spcAft>
-              <a:defRPr sz="1700">
+              <a:defRPr sz="1100" b="1">
+                <a:solidFill>
+                  <a:srgbClr val="1B5E20"/>
+                </a:solidFill>
+                <a:latin typeface="Calibri"/>
+              </a:defRPr>
+            </a:pPr>
+            <a:r>
+              <a:t>SQL (copy into DBeaver on soccer_proj):</a:t>
+            </a:r>
+          </a:p>
+          <a:p>
+            <a:pPr>
+              <a:spcBef>
+                <a:spcPts val="400"/>
+              </a:spcBef>
+              <a:defRPr sz="900">
                 <a:solidFill>
                   <a:srgbClr val="212121"/>
                 </a:solidFill>
-                <a:latin typeface="Calibri"/>
+                <a:latin typeface="Consolas"/>
               </a:defRPr>
             </a:pPr>
             <a:r>
-              <a:t>Tables: Match_tbl → League → Country (3-table join)</a:t>
-            </a:r>
-          </a:p>
-          <a:p>
-            <a:pPr>
-              <a:spcAft>
-                <a:spcPts val="1000"/>
-              </a:spcAft>
-              <a:defRPr sz="1700">
-                <a:solidFill>
-                  <a:srgbClr val="212121"/>
-                </a:solidFill>
-                <a:latin typeface="Calibri"/>
-              </a:defRPr>
-            </a:pPr>
-            <a:r>
-              <a:t>Techniques: INNER JOIN (inner join), GROUP BY country, AVG of home + away goals</a:t>
+              <a:t>SELECT c.name AS country,</a:t>
+            </a:r>
+            <a:br/>
+            <a:r>
+              <a:t>  AVG((m.home_team_goal + m.away_team_goal)::numeric) AS avg_goals_per_match</a:t>
+            </a:r>
+            <a:br/>
+            <a:r>
+              <a:t>FROM soccer_proj."Match_tbl" m</a:t>
+            </a:r>
+            <a:br/>
+            <a:r>
+              <a:t>JOIN soccer_proj."League" l ON l.id = m.league_id</a:t>
+            </a:r>
+            <a:br/>
+            <a:r>
+              <a:t>JOIN soccer_proj."Country" c ON c.id = l.country_id</a:t>
+            </a:r>
+            <a:br/>
+            <a:r>
+              <a:t>GROUP BY c.name</a:t>
+            </a:r>
+            <a:br/>
+            <a:r>
+              <a:t>ORDER BY avg_goals_per_match DESC;</a:t>
             </a:r>
           </a:p>
         </p:txBody>
@@ -4691,7 +4971,7 @@
               </a:defRPr>
             </a:pPr>
             <a:r>
-              <a:t>DEMO: Advanced query (Q18)</a:t>
+              <a:t>DEMO Q16 — Query results</a:t>
             </a:r>
           </a:p>
           <a:p>
@@ -4704,98 +4984,35 @@
               </a:defRPr>
             </a:pPr>
             <a:r>
-              <a:t>Join with OR + conditional aggregates</a:t>
-            </a:r>
-          </a:p>
-        </p:txBody>
-      </p:sp>
-      <p:sp>
-        <p:nvSpPr>
-          <p:cNvPr id="3" name="TextBox 2"/>
-          <p:cNvSpPr txBox="1"/>
+              <a:t>DBeaver · demo1 · Netherlands leads avg goals per match</a:t>
+            </a:r>
+          </a:p>
+        </p:txBody>
+      </p:sp>
+      <p:pic>
+        <p:nvPicPr>
+          <p:cNvPr id="3" name="Picture 2" descr="demo_q16_results.png"/>
+          <p:cNvPicPr>
+            <a:picLocks noChangeAspect="1"/>
+          </p:cNvPicPr>
           <p:nvPr/>
-        </p:nvSpPr>
+        </p:nvPicPr>
+        <p:blipFill>
+          <a:blip r:embed="rId2"/>
+          <a:stretch>
+            <a:fillRect/>
+          </a:stretch>
+        </p:blipFill>
         <p:spPr>
           <a:xfrm>
-            <a:off x="548640" y="1234440"/>
-            <a:ext cx="8046720" cy="5029200"/>
+            <a:off x="320040" y="1005840"/>
+            <a:ext cx="8503920" cy="4426357"/>
           </a:xfrm>
           <a:prstGeom prst="rect">
             <a:avLst/>
           </a:prstGeom>
-          <a:noFill/>
         </p:spPr>
-        <p:txBody>
-          <a:bodyPr wrap="square">
-            <a:spAutoFit/>
-          </a:bodyPr>
-          <a:lstStyle/>
-          <a:p>
-            <a:pPr>
-              <a:spcAft>
-                <a:spcPts val="1000"/>
-              </a:spcAft>
-              <a:defRPr sz="1700">
-                <a:solidFill>
-                  <a:srgbClr val="212121"/>
-                </a:solidFill>
-                <a:latin typeface="Calibri"/>
-              </a:defRPr>
-            </a:pPr>
-            <a:r>
-              <a:t>Question: Which teams most frequently kept clean sheets?</a:t>
-            </a:r>
-          </a:p>
-          <a:p>
-            <a:pPr>
-              <a:spcAft>
-                <a:spcPts val="1000"/>
-              </a:spcAft>
-              <a:defRPr sz="1700">
-                <a:solidFill>
-                  <a:srgbClr val="212121"/>
-                </a:solidFill>
-                <a:latin typeface="Calibri"/>
-              </a:defRPr>
-            </a:pPr>
-            <a:r>
-              <a:t>Business use: defensive KPI for scouting, tactics, and “best defense” style rankings</a:t>
-            </a:r>
-          </a:p>
-          <a:p>
-            <a:pPr>
-              <a:spcAft>
-                <a:spcPts val="1000"/>
-              </a:spcAft>
-              <a:defRPr sz="1700">
-                <a:solidFill>
-                  <a:srgbClr val="212121"/>
-                </a:solidFill>
-                <a:latin typeface="Calibri"/>
-              </a:defRPr>
-            </a:pPr>
-            <a:r>
-              <a:t>Tables: Team joined to Match_tbl (team is home OR away)</a:t>
-            </a:r>
-          </a:p>
-          <a:p>
-            <a:pPr>
-              <a:spcAft>
-                <a:spcPts val="1000"/>
-              </a:spcAft>
-              <a:defRPr sz="1700">
-                <a:solidFill>
-                  <a:srgbClr val="212121"/>
-                </a:solidFill>
-                <a:latin typeface="Calibri"/>
-              </a:defRPr>
-            </a:pPr>
-            <a:r>
-              <a:t>Techniques: join using OR (home or away), two CASE expressions inside SUM, GROUP BY, ORDER BY</a:t>
-            </a:r>
-          </a:p>
-        </p:txBody>
-      </p:sp>
+      </p:pic>
     </p:spTree>
   </p:cSld>
   <p:clrMapOvr>
@@ -4845,6 +5062,303 @@
               </a:defRPr>
             </a:pPr>
             <a:r>
+              <a:t>DEMO: Advanced query (Q18)</a:t>
+            </a:r>
+          </a:p>
+          <a:p>
+            <a:pPr>
+              <a:defRPr sz="1600">
+                <a:solidFill>
+                  <a:srgbClr val="555555"/>
+                </a:solidFill>
+                <a:latin typeface="Calibri"/>
+              </a:defRPr>
+            </a:pPr>
+            <a:r>
+              <a:t>Join with OR + conditional aggregates</a:t>
+            </a:r>
+          </a:p>
+        </p:txBody>
+      </p:sp>
+      <p:sp>
+        <p:nvSpPr>
+          <p:cNvPr id="3" name="TextBox 2"/>
+          <p:cNvSpPr txBox="1"/>
+          <p:nvPr/>
+        </p:nvSpPr>
+        <p:spPr>
+          <a:xfrm>
+            <a:off x="548640" y="1143000"/>
+            <a:ext cx="8046720" cy="1920240"/>
+          </a:xfrm>
+          <a:prstGeom prst="rect">
+            <a:avLst/>
+          </a:prstGeom>
+          <a:noFill/>
+        </p:spPr>
+        <p:txBody>
+          <a:bodyPr wrap="square">
+            <a:spAutoFit/>
+          </a:bodyPr>
+          <a:lstStyle/>
+          <a:p>
+            <a:pPr>
+              <a:spcAft>
+                <a:spcPts val="1000"/>
+              </a:spcAft>
+              <a:defRPr sz="1600">
+                <a:solidFill>
+                  <a:srgbClr val="212121"/>
+                </a:solidFill>
+                <a:latin typeface="Calibri"/>
+              </a:defRPr>
+            </a:pPr>
+            <a:r>
+              <a:t>Question: Which teams most frequently kept clean sheets?</a:t>
+            </a:r>
+          </a:p>
+          <a:p>
+            <a:pPr>
+              <a:spcAft>
+                <a:spcPts val="1000"/>
+              </a:spcAft>
+              <a:defRPr sz="1600">
+                <a:solidFill>
+                  <a:srgbClr val="212121"/>
+                </a:solidFill>
+                <a:latin typeface="Calibri"/>
+              </a:defRPr>
+            </a:pPr>
+            <a:r>
+              <a:t>Tables: Team + Match_tbl · JOIN with OR · two CASE inside SUM · GROUP BY</a:t>
+            </a:r>
+          </a:p>
+        </p:txBody>
+      </p:sp>
+      <p:sp>
+        <p:nvSpPr>
+          <p:cNvPr id="4" name="TextBox 3"/>
+          <p:cNvSpPr txBox="1"/>
+          <p:nvPr/>
+        </p:nvSpPr>
+        <p:spPr>
+          <a:xfrm>
+            <a:off x="502920" y="3246120"/>
+            <a:ext cx="8138160" cy="3200400"/>
+          </a:xfrm>
+          <a:prstGeom prst="rect">
+            <a:avLst/>
+          </a:prstGeom>
+          <a:noFill/>
+        </p:spPr>
+        <p:txBody>
+          <a:bodyPr wrap="square">
+            <a:spAutoFit/>
+          </a:bodyPr>
+          <a:lstStyle/>
+          <a:p>
+            <a:pPr>
+              <a:defRPr sz="1100" b="1">
+                <a:solidFill>
+                  <a:srgbClr val="1B5E20"/>
+                </a:solidFill>
+                <a:latin typeface="Calibri"/>
+              </a:defRPr>
+            </a:pPr>
+            <a:r>
+              <a:t>SQL (copy into DBeaver on soccer_proj):</a:t>
+            </a:r>
+          </a:p>
+          <a:p>
+            <a:pPr>
+              <a:spcBef>
+                <a:spcPts val="400"/>
+              </a:spcBef>
+              <a:defRPr sz="800">
+                <a:solidFill>
+                  <a:srgbClr val="212121"/>
+                </a:solidFill>
+                <a:latin typeface="Consolas"/>
+              </a:defRPr>
+            </a:pPr>
+            <a:r>
+              <a:t>SELECT t.team_long_name,</a:t>
+            </a:r>
+            <a:br/>
+            <a:r>
+              <a:t>  SUM(CASE WHEN m.home_team_api_id = t.team_api_id AND m.away_team_goal = 0 THEN 1 ELSE 0 END</a:t>
+            </a:r>
+            <a:br/>
+            <a:r>
+              <a:t>     + CASE WHEN m.away_team_api_id = t.team_api_id AND m.home_team_goal = 0 THEN 1 ELSE 0 END) AS clean_sheets</a:t>
+            </a:r>
+            <a:br/>
+            <a:r>
+              <a:t>FROM soccer_proj."Team" t</a:t>
+            </a:r>
+            <a:br/>
+            <a:r>
+              <a:t>JOIN soccer_proj."Match_tbl" m</a:t>
+            </a:r>
+            <a:br/>
+            <a:r>
+              <a:t>  ON m.home_team_api_id = t.team_api_id OR m.away_team_api_id = t.team_api_id</a:t>
+            </a:r>
+            <a:br/>
+            <a:r>
+              <a:t>GROUP BY t.team_long_name</a:t>
+            </a:r>
+            <a:br/>
+            <a:r>
+              <a:t>ORDER BY clean_sheets DESC</a:t>
+            </a:r>
+            <a:br/>
+            <a:r>
+              <a:t>LIMIT 30;</a:t>
+            </a:r>
+          </a:p>
+        </p:txBody>
+      </p:sp>
+    </p:spTree>
+  </p:cSld>
+  <p:clrMapOvr>
+    <a:masterClrMapping/>
+  </p:clrMapOvr>
+</p:sld>
+</file>
+
+<file path=ppt/slides/slide13.xml><?xml version="1.0" encoding="utf-8"?>
+<p:sld xmlns:a="http://schemas.openxmlformats.org/drawingml/2006/main" xmlns:p="http://schemas.openxmlformats.org/presentationml/2006/main" xmlns:r="http://schemas.openxmlformats.org/officeDocument/2006/relationships">
+  <p:cSld>
+    <p:spTree>
+      <p:nvGrpSpPr>
+        <p:cNvPr id="1" name=""/>
+        <p:cNvGrpSpPr/>
+        <p:nvPr/>
+      </p:nvGrpSpPr>
+      <p:grpSpPr/>
+      <p:sp>
+        <p:nvSpPr>
+          <p:cNvPr id="2" name="TextBox 1"/>
+          <p:cNvSpPr txBox="1"/>
+          <p:nvPr/>
+        </p:nvSpPr>
+        <p:spPr>
+          <a:xfrm>
+            <a:off x="457200" y="320040"/>
+            <a:ext cx="8229600" cy="822960"/>
+          </a:xfrm>
+          <a:prstGeom prst="rect">
+            <a:avLst/>
+          </a:prstGeom>
+          <a:noFill/>
+        </p:spPr>
+        <p:txBody>
+          <a:bodyPr wrap="none">
+            <a:spAutoFit/>
+          </a:bodyPr>
+          <a:lstStyle/>
+          <a:p>
+            <a:pPr>
+              <a:defRPr sz="3200" b="1">
+                <a:solidFill>
+                  <a:srgbClr val="1B5E20"/>
+                </a:solidFill>
+                <a:latin typeface="Calibri"/>
+              </a:defRPr>
+            </a:pPr>
+            <a:r>
+              <a:t>DEMO Q18 — Query results</a:t>
+            </a:r>
+          </a:p>
+          <a:p>
+            <a:pPr>
+              <a:defRPr sz="1600">
+                <a:solidFill>
+                  <a:srgbClr val="555555"/>
+                </a:solidFill>
+                <a:latin typeface="Calibri"/>
+              </a:defRPr>
+            </a:pPr>
+            <a:r>
+              <a:t>DBeaver · demo2 · Celtic leads clean sheets</a:t>
+            </a:r>
+          </a:p>
+        </p:txBody>
+      </p:sp>
+      <p:pic>
+        <p:nvPicPr>
+          <p:cNvPr id="3" name="Picture 2" descr="demo_q18_results.png"/>
+          <p:cNvPicPr>
+            <a:picLocks noChangeAspect="1"/>
+          </p:cNvPicPr>
+          <p:nvPr/>
+        </p:nvPicPr>
+        <p:blipFill>
+          <a:blip r:embed="rId2"/>
+          <a:stretch>
+            <a:fillRect/>
+          </a:stretch>
+        </p:blipFill>
+        <p:spPr>
+          <a:xfrm>
+            <a:off x="320040" y="1005840"/>
+            <a:ext cx="8503920" cy="4550926"/>
+          </a:xfrm>
+          <a:prstGeom prst="rect">
+            <a:avLst/>
+          </a:prstGeom>
+        </p:spPr>
+      </p:pic>
+    </p:spTree>
+  </p:cSld>
+  <p:clrMapOvr>
+    <a:masterClrMapping/>
+  </p:clrMapOvr>
+</p:sld>
+</file>
+
+<file path=ppt/slides/slide14.xml><?xml version="1.0" encoding="utf-8"?>
+<p:sld xmlns:a="http://schemas.openxmlformats.org/drawingml/2006/main" xmlns:p="http://schemas.openxmlformats.org/presentationml/2006/main" xmlns:r="http://schemas.openxmlformats.org/officeDocument/2006/relationships">
+  <p:cSld>
+    <p:spTree>
+      <p:nvGrpSpPr>
+        <p:cNvPr id="1" name=""/>
+        <p:cNvGrpSpPr/>
+        <p:nvPr/>
+      </p:nvGrpSpPr>
+      <p:grpSpPr/>
+      <p:sp>
+        <p:nvSpPr>
+          <p:cNvPr id="2" name="TextBox 1"/>
+          <p:cNvSpPr txBox="1"/>
+          <p:nvPr/>
+        </p:nvSpPr>
+        <p:spPr>
+          <a:xfrm>
+            <a:off x="457200" y="320040"/>
+            <a:ext cx="8229600" cy="822960"/>
+          </a:xfrm>
+          <a:prstGeom prst="rect">
+            <a:avLst/>
+          </a:prstGeom>
+          <a:noFill/>
+        </p:spPr>
+        <p:txBody>
+          <a:bodyPr wrap="none">
+            <a:spAutoFit/>
+          </a:bodyPr>
+          <a:lstStyle/>
+          <a:p>
+            <a:pPr>
+              <a:defRPr sz="3200" b="1">
+                <a:solidFill>
+                  <a:srgbClr val="1B5E20"/>
+                </a:solidFill>
+                <a:latin typeface="Calibri"/>
+              </a:defRPr>
+            </a:pPr>
+            <a:r>
               <a:t>Business applications</a:t>
             </a:r>
           </a:p>
@@ -4974,7 +5488,7 @@
 </p:sld>
 </file>
 
-<file path=ppt/slides/slide13.xml><?xml version="1.0" encoding="utf-8"?>
+<file path=ppt/slides/slide15.xml><?xml version="1.0" encoding="utf-8"?>
 <p:sld xmlns:a="http://schemas.openxmlformats.org/drawingml/2006/main" xmlns:p="http://schemas.openxmlformats.org/presentationml/2006/main" xmlns:r="http://schemas.openxmlformats.org/officeDocument/2006/relationships">
   <p:cSld>
     <p:spTree>

</xml_diff>